<commit_message>
Point everything at dokett-console.vercel.app
The Console still answered on covenant-console.vercel.app, and that URL
was baked into the capture guide, demo script and submission copy — so
it would have appeared in the browser bar on camera. Worse than merely
stale: "covenant" is the name of the competing submission in the same
track, so the video would have shown a judge the other team's name while
the site said Dokett.

Vercel's CLI has no project rename, but `vercel alias` assigns a free
.vercel.app subdomain to a deployment, which achieves the same thing
without a dashboard visit. The old URL still resolves, so nothing that
already links to it breaks.

15 files updated, OG cards and deck regenerated with the new URL baked
into the images and the footer.
</commit_message>
<xml_diff>
--- a/docs/deck/dokett-deck.pptx
+++ b/docs/deck/dokett-deck.pptx
@@ -2911,7 +2911,7 @@
                 <a:ea typeface="Courier New" pitchFamily="34" charset="-122"/>
                 <a:cs typeface="Courier New" pitchFamily="34" charset="-120"/>
               </a:rPr>
-              <a:t>covenant-console.vercel.app</a:t>
+              <a:t>dokett-console.vercel.app</a:t>
             </a:r>
             <a:endParaRPr lang="en-US" sz="1300" dirty="0"/>
           </a:p>
@@ -2950,7 +2950,7 @@
                 <a:ea typeface="Courier New" pitchFamily="34" charset="-122"/>
                 <a:cs typeface="Courier New" pitchFamily="34" charset="-120"/>
               </a:rPr>
-              <a:t>covenant-lens.fly.dev</a:t>
+              <a:t>dokett-lens.fly.dev</a:t>
             </a:r>
             <a:endParaRPr lang="en-US" sz="1300" dirty="0"/>
           </a:p>
@@ -2989,7 +2989,7 @@
                 <a:ea typeface="Courier New" pitchFamily="34" charset="-122"/>
                 <a:cs typeface="Courier New" pitchFamily="34" charset="-120"/>
               </a:rPr>
-              <a:t>github.com/successaje/covenant</a:t>
+              <a:t>github.com/successaje/Dokett</a:t>
             </a:r>
             <a:endParaRPr lang="en-US" sz="1300" dirty="0"/>
           </a:p>

</xml_diff>